<commit_message>
updated theory 9 and lab 7
</commit_message>
<xml_diff>
--- a/theory_08-elements_of_network_security/theory_08-elements_of_network_security.pptx
+++ b/theory_08-elements_of_network_security/theory_08-elements_of_network_security.pptx
@@ -226,7 +226,7 @@
           <a:p>
             <a:fld id="{251090E0-FB0C-49E9-9864-9F53EABEA96F}" type="datetimeFigureOut">
               <a:rPr lang="en-GB" smtClean="0"/>
-              <a:t>07/04/2025</a:t>
+              <a:t>15/04/2025</a:t>
             </a:fld>
             <a:endParaRPr lang="en-GB"/>
           </a:p>
@@ -9714,13 +9714,15 @@
       <p:cxnSp>
         <p:nvCxnSpPr>
           <p:cNvPr id="27" name="Connettore 2 26"/>
-          <p:cNvCxnSpPr/>
+          <p:cNvCxnSpPr>
+            <a:cxnSpLocks/>
+          </p:cNvCxnSpPr>
           <p:nvPr/>
         </p:nvCxnSpPr>
         <p:spPr>
           <a:xfrm>
-            <a:off x="10208140" y="4675752"/>
-            <a:ext cx="4108" cy="368280"/>
+            <a:off x="9809018" y="4643752"/>
+            <a:ext cx="403230" cy="400280"/>
           </a:xfrm>
           <a:prstGeom prst="straightConnector1">
             <a:avLst/>
@@ -9781,13 +9783,15 @@
       <p:cxnSp>
         <p:nvCxnSpPr>
           <p:cNvPr id="45" name="Connettore 2 44"/>
-          <p:cNvCxnSpPr/>
+          <p:cNvCxnSpPr>
+            <a:cxnSpLocks/>
+          </p:cNvCxnSpPr>
           <p:nvPr/>
         </p:nvCxnSpPr>
         <p:spPr>
           <a:xfrm flipH="1">
-            <a:off x="8521966" y="4605469"/>
-            <a:ext cx="387419" cy="315918"/>
+            <a:off x="8521966" y="4593764"/>
+            <a:ext cx="297838" cy="327623"/>
           </a:xfrm>
           <a:prstGeom prst="straightConnector1">
             <a:avLst/>
@@ -13127,7 +13131,7 @@
           <a:p>
             <a:r>
               <a:rPr lang="en-US" sz="2200" dirty="0">
-                <a:latin typeface="Palatino Linotype" panose="02040502050505030304" pitchFamily="18" charset="0"/>
+                <a:latin typeface="Aptos" panose="020B0004020202020204" pitchFamily="34" charset="0"/>
               </a:rPr>
               <a:t>If the two digest are the same Bob can be sure that the message was sent by Alice, because otherwise the decrypted hash would differ from the one obtained by Bob. </a:t>
             </a:r>
@@ -13135,73 +13139,73 @@
           <a:p>
             <a:r>
               <a:rPr lang="en-US" sz="2200" dirty="0">
-                <a:latin typeface="Palatino Linotype" panose="02040502050505030304" pitchFamily="18" charset="0"/>
+                <a:latin typeface="Aptos" panose="020B0004020202020204" pitchFamily="34" charset="0"/>
                 <a:sym typeface="Wingdings" panose="05000000000000000000" pitchFamily="2" charset="2"/>
               </a:rPr>
               <a:t> </a:t>
             </a:r>
             <a:r>
               <a:rPr lang="en-US" sz="2200" b="1" dirty="0">
-                <a:latin typeface="Palatino Linotype" panose="02040502050505030304" pitchFamily="18" charset="0"/>
+                <a:latin typeface="Aptos" panose="020B0004020202020204" pitchFamily="34" charset="0"/>
                 <a:sym typeface="Wingdings" panose="05000000000000000000" pitchFamily="2" charset="2"/>
               </a:rPr>
               <a:t>Authentication</a:t>
             </a:r>
             <a:r>
               <a:rPr lang="en-US" sz="2200" dirty="0">
-                <a:latin typeface="Palatino Linotype" panose="02040502050505030304" pitchFamily="18" charset="0"/>
+                <a:latin typeface="Aptos" panose="020B0004020202020204" pitchFamily="34" charset="0"/>
                 <a:sym typeface="Wingdings" panose="05000000000000000000" pitchFamily="2" charset="2"/>
               </a:rPr>
               <a:t> and </a:t>
             </a:r>
             <a:r>
               <a:rPr lang="en-US" sz="2200" b="1" dirty="0">
-                <a:latin typeface="Palatino Linotype" panose="02040502050505030304" pitchFamily="18" charset="0"/>
+                <a:latin typeface="Aptos" panose="020B0004020202020204" pitchFamily="34" charset="0"/>
                 <a:sym typeface="Wingdings" panose="05000000000000000000" pitchFamily="2" charset="2"/>
               </a:rPr>
               <a:t>non-repudiation</a:t>
             </a:r>
             <a:r>
               <a:rPr lang="en-US" sz="2200" dirty="0">
-                <a:latin typeface="Palatino Linotype" panose="02040502050505030304" pitchFamily="18" charset="0"/>
+                <a:latin typeface="Aptos" panose="020B0004020202020204" pitchFamily="34" charset="0"/>
                 <a:sym typeface="Wingdings" panose="05000000000000000000" pitchFamily="2" charset="2"/>
               </a:rPr>
               <a:t> ensured.</a:t>
             </a:r>
             <a:endParaRPr lang="en-US" sz="2200" dirty="0">
-              <a:latin typeface="Palatino Linotype" panose="02040502050505030304" pitchFamily="18" charset="0"/>
+              <a:latin typeface="Aptos" panose="020B0004020202020204" pitchFamily="34" charset="0"/>
             </a:endParaRPr>
           </a:p>
           <a:p>
             <a:r>
               <a:rPr lang="en-US" sz="2200" dirty="0">
-                <a:latin typeface="Palatino Linotype" panose="02040502050505030304" pitchFamily="18" charset="0"/>
+                <a:latin typeface="Aptos" panose="020B0004020202020204" pitchFamily="34" charset="0"/>
               </a:rPr>
               <a:t>Bob is also sure that the message P was not altered during transmission. Any small modification of P would result in a different digest! </a:t>
             </a:r>
             <a:r>
               <a:rPr lang="en-US" sz="2200" dirty="0">
-                <a:latin typeface="Palatino Linotype" panose="02040502050505030304" pitchFamily="18" charset="0"/>
+                <a:latin typeface="Aptos" panose="020B0004020202020204" pitchFamily="34" charset="0"/>
                 <a:sym typeface="Wingdings" panose="05000000000000000000" pitchFamily="2" charset="2"/>
               </a:rPr>
               <a:t> </a:t>
             </a:r>
             <a:r>
               <a:rPr lang="en-US" sz="2200" b="1" dirty="0">
-                <a:latin typeface="Palatino Linotype" panose="02040502050505030304" pitchFamily="18" charset="0"/>
+                <a:latin typeface="Aptos" panose="020B0004020202020204" pitchFamily="34" charset="0"/>
                 <a:sym typeface="Wingdings" panose="05000000000000000000" pitchFamily="2" charset="2"/>
               </a:rPr>
               <a:t>Integrity</a:t>
             </a:r>
             <a:r>
               <a:rPr lang="en-US" sz="2200" dirty="0">
-                <a:latin typeface="Palatino Linotype" panose="02040502050505030304" pitchFamily="18" charset="0"/>
+                <a:latin typeface="Aptos" panose="020B0004020202020204" pitchFamily="34" charset="0"/>
                 <a:sym typeface="Wingdings" panose="05000000000000000000" pitchFamily="2" charset="2"/>
               </a:rPr>
               <a:t> ensured. </a:t>
             </a:r>
             <a:endParaRPr lang="en-US" sz="2200" dirty="0">
-              <a:latin typeface="Palatino Linotype" panose="02040502050505030304" pitchFamily="18" charset="0"/>
+              <a:latin typeface="Aptos" panose="020B0004020202020204" pitchFamily="34" charset="0"/>
             </a:endParaRPr>
           </a:p>
         </p:txBody>

</xml_diff>